<commit_message>
Poster: fill spare space in every box; add verification-test notebook
</commit_message>
<xml_diff>
--- a/poster/Poster_Sarkar_Choudhuri_Project1.pptx
+++ b/poster/Poster_Sarkar_Choudhuri_Project1.pptx
@@ -3951,11 +3951,11 @@
                 <a:spcPct val="105000"/>
               </a:lnSpc>
               <a:spcAft>
-                <a:spcPts val="600"/>
+                <a:spcPts val="900"/>
               </a:spcAft>
             </a:pPr>
             <a:r>
-              <a:rPr sz="2400" b="1">
+              <a:rPr sz="2550" b="1">
                 <a:solidFill>
                   <a:srgbClr val="1A1A1A"/>
                 </a:solidFill>
@@ -3964,13 +3964,13 @@
               <a:t>PO1 </a:t>
             </a:r>
             <a:r>
-              <a:rPr sz="2400" b="0">
-                <a:solidFill>
-                  <a:srgbClr val="1A1A1A"/>
-                </a:solidFill>
-                <a:latin typeface="Calibri"/>
-              </a:rPr>
-              <a:t>Linear algebra, optimisation and inverse-problem theory applied to a neural operator.</a:t>
+              <a:rPr sz="2550" b="0">
+                <a:solidFill>
+                  <a:srgbClr val="1A1A1A"/>
+                </a:solidFill>
+                <a:latin typeface="Calibri"/>
+              </a:rPr>
+              <a:t>Linear algebra, optimisation and inverse-problem theory.</a:t>
             </a:r>
           </a:p>
           <a:p>
@@ -3979,11 +3979,11 @@
                 <a:spcPct val="105000"/>
               </a:lnSpc>
               <a:spcAft>
-                <a:spcPts val="600"/>
+                <a:spcPts val="900"/>
               </a:spcAft>
             </a:pPr>
             <a:r>
-              <a:rPr sz="2400" b="1">
+              <a:rPr sz="2550" b="1">
                 <a:solidFill>
                   <a:srgbClr val="1A1A1A"/>
                 </a:solidFill>
@@ -3992,7 +3992,7 @@
               <a:t>PO2 </a:t>
             </a:r>
             <a:r>
-              <a:rPr sz="2400" b="0">
+              <a:rPr sz="2550" b="0">
                 <a:solidFill>
                   <a:srgbClr val="1A1A1A"/>
                 </a:solidFill>
@@ -4007,26 +4007,26 @@
                 <a:spcPct val="105000"/>
               </a:lnSpc>
               <a:spcAft>
-                <a:spcPts val="600"/>
+                <a:spcPts val="900"/>
               </a:spcAft>
             </a:pPr>
             <a:r>
-              <a:rPr sz="2400" b="1">
-                <a:solidFill>
-                  <a:srgbClr val="1A1A1A"/>
-                </a:solidFill>
-                <a:latin typeface="Calibri"/>
-              </a:rPr>
-              <a:t>PO4 </a:t>
-            </a:r>
-            <a:r>
-              <a:rPr sz="2400" b="0">
-                <a:solidFill>
-                  <a:srgbClr val="1A1A1A"/>
-                </a:solidFill>
-                <a:latin typeface="Calibri"/>
-              </a:rPr>
-              <a:t>Designed controlled experiments with exact ground truth and matched controls.</a:t>
+              <a:rPr sz="2550" b="1">
+                <a:solidFill>
+                  <a:srgbClr val="1A1A1A"/>
+                </a:solidFill>
+                <a:latin typeface="Calibri"/>
+              </a:rPr>
+              <a:t>PO3 </a:t>
+            </a:r>
+            <a:r>
+              <a:rPr sz="2550" b="0">
+                <a:solidFill>
+                  <a:srgbClr val="1A1A1A"/>
+                </a:solidFill>
+                <a:latin typeface="Calibri"/>
+              </a:rPr>
+              <a:t>Designed the inversion pipeline and its controls.</a:t>
             </a:r>
           </a:p>
           <a:p>
@@ -4035,26 +4035,26 @@
                 <a:spcPct val="105000"/>
               </a:lnSpc>
               <a:spcAft>
-                <a:spcPts val="600"/>
+                <a:spcPts val="900"/>
               </a:spcAft>
             </a:pPr>
             <a:r>
-              <a:rPr sz="2400" b="1">
-                <a:solidFill>
-                  <a:srgbClr val="1A1A1A"/>
-                </a:solidFill>
-                <a:latin typeface="Calibri"/>
-              </a:rPr>
-              <a:t>PO5 </a:t>
-            </a:r>
-            <a:r>
-              <a:rPr sz="2400" b="0">
-                <a:solidFill>
-                  <a:srgbClr val="1A1A1A"/>
-                </a:solidFill>
-                <a:latin typeface="Calibri"/>
-              </a:rPr>
-              <a:t>PyTorch, TRIBE v2, ANTs, nilearn, GPU (Colab) computing.</a:t>
+              <a:rPr sz="2550" b="1">
+                <a:solidFill>
+                  <a:srgbClr val="1A1A1A"/>
+                </a:solidFill>
+                <a:latin typeface="Calibri"/>
+              </a:rPr>
+              <a:t>PO4 </a:t>
+            </a:r>
+            <a:r>
+              <a:rPr sz="2550" b="0">
+                <a:solidFill>
+                  <a:srgbClr val="1A1A1A"/>
+                </a:solidFill>
+                <a:latin typeface="Calibri"/>
+              </a:rPr>
+              <a:t>Designed controlled experiments with exact ground truth and matched controls.</a:t>
             </a:r>
           </a:p>
           <a:p>
@@ -4063,26 +4063,26 @@
                 <a:spcPct val="105000"/>
               </a:lnSpc>
               <a:spcAft>
-                <a:spcPts val="600"/>
+                <a:spcPts val="900"/>
               </a:spcAft>
             </a:pPr>
             <a:r>
-              <a:rPr sz="2400" b="1">
-                <a:solidFill>
-                  <a:srgbClr val="1A1A1A"/>
-                </a:solidFill>
-                <a:latin typeface="Calibri"/>
-              </a:rPr>
-              <a:t>PO6, PO8 </a:t>
-            </a:r>
-            <a:r>
-              <a:rPr sz="2400" b="0">
-                <a:solidFill>
-                  <a:srgbClr val="1A1A1A"/>
-                </a:solidFill>
-                <a:latin typeface="Calibri"/>
-              </a:rPr>
-              <a:t>Mental-privacy and clinical-use implications; open data, licences respected.</a:t>
+              <a:rPr sz="2550" b="1">
+                <a:solidFill>
+                  <a:srgbClr val="1A1A1A"/>
+                </a:solidFill>
+                <a:latin typeface="Calibri"/>
+              </a:rPr>
+              <a:t>PO5 </a:t>
+            </a:r>
+            <a:r>
+              <a:rPr sz="2550" b="0">
+                <a:solidFill>
+                  <a:srgbClr val="1A1A1A"/>
+                </a:solidFill>
+                <a:latin typeface="Calibri"/>
+              </a:rPr>
+              <a:t>PyTorch, TRIBE v2, ANTs, nilearn, GPU (Colab) computing.</a:t>
             </a:r>
           </a:p>
           <a:p>
@@ -4091,26 +4091,26 @@
                 <a:spcPct val="105000"/>
               </a:lnSpc>
               <a:spcAft>
-                <a:spcPts val="600"/>
+                <a:spcPts val="900"/>
               </a:spcAft>
             </a:pPr>
             <a:r>
-              <a:rPr sz="2400" b="1">
-                <a:solidFill>
-                  <a:srgbClr val="1A1A1A"/>
-                </a:solidFill>
-                <a:latin typeface="Calibri"/>
-              </a:rPr>
-              <a:t>PO9, PO10 </a:t>
-            </a:r>
-            <a:r>
-              <a:rPr sz="2400" b="0">
-                <a:solidFill>
-                  <a:srgbClr val="1A1A1A"/>
-                </a:solidFill>
-                <a:latin typeface="Calibri"/>
-              </a:rPr>
-              <a:t>Two-track teamwork; IEEE manuscript, poster, reviews.</a:t>
+              <a:rPr sz="2550" b="1">
+                <a:solidFill>
+                  <a:srgbClr val="1A1A1A"/>
+                </a:solidFill>
+                <a:latin typeface="Calibri"/>
+              </a:rPr>
+              <a:t>PO6, PO8 </a:t>
+            </a:r>
+            <a:r>
+              <a:rPr sz="2550" b="0">
+                <a:solidFill>
+                  <a:srgbClr val="1A1A1A"/>
+                </a:solidFill>
+                <a:latin typeface="Calibri"/>
+              </a:rPr>
+              <a:t>Mental privacy and clinical use; licences respected.</a:t>
             </a:r>
           </a:p>
           <a:p>
@@ -4119,26 +4119,26 @@
                 <a:spcPct val="105000"/>
               </a:lnSpc>
               <a:spcAft>
-                <a:spcPts val="600"/>
+                <a:spcPts val="900"/>
               </a:spcAft>
             </a:pPr>
             <a:r>
-              <a:rPr sz="2400" b="1">
-                <a:solidFill>
-                  <a:srgbClr val="1A1A1A"/>
-                </a:solidFill>
-                <a:latin typeface="Calibri"/>
-              </a:rPr>
-              <a:t>PO12 </a:t>
-            </a:r>
-            <a:r>
-              <a:rPr sz="2400" b="0">
-                <a:solidFill>
-                  <a:srgbClr val="1A1A1A"/>
-                </a:solidFill>
-                <a:latin typeface="Calibri"/>
-              </a:rPr>
-              <a:t>Self-taught foundation models and neuroimaging tools.</a:t>
+              <a:rPr sz="2550" b="1">
+                <a:solidFill>
+                  <a:srgbClr val="1A1A1A"/>
+                </a:solidFill>
+                <a:latin typeface="Calibri"/>
+              </a:rPr>
+              <a:t>PO9, PO10 </a:t>
+            </a:r>
+            <a:r>
+              <a:rPr sz="2550" b="0">
+                <a:solidFill>
+                  <a:srgbClr val="1A1A1A"/>
+                </a:solidFill>
+                <a:latin typeface="Calibri"/>
+              </a:rPr>
+              <a:t>Two-track teamwork; IEEE manuscript, poster, reviews.</a:t>
             </a:r>
           </a:p>
           <a:p>
@@ -4147,11 +4147,39 @@
                 <a:spcPct val="105000"/>
               </a:lnSpc>
               <a:spcAft>
-                <a:spcPts val="600"/>
+                <a:spcPts val="900"/>
               </a:spcAft>
             </a:pPr>
             <a:r>
-              <a:rPr sz="2400" b="1">
+              <a:rPr sz="2550" b="1">
+                <a:solidFill>
+                  <a:srgbClr val="1A1A1A"/>
+                </a:solidFill>
+                <a:latin typeface="Calibri"/>
+              </a:rPr>
+              <a:t>PO12 </a:t>
+            </a:r>
+            <a:r>
+              <a:rPr sz="2550" b="0">
+                <a:solidFill>
+                  <a:srgbClr val="1A1A1A"/>
+                </a:solidFill>
+                <a:latin typeface="Calibri"/>
+              </a:rPr>
+              <a:t>Self-taught foundation models and neuroimaging tools.</a:t>
+            </a:r>
+          </a:p>
+          <a:p>
+            <a:pPr>
+              <a:lnSpc>
+                <a:spcPct val="105000"/>
+              </a:lnSpc>
+              <a:spcAft>
+                <a:spcPts val="900"/>
+              </a:spcAft>
+            </a:pPr>
+            <a:r>
+              <a:rPr sz="2550" b="1">
                 <a:solidFill>
                   <a:srgbClr val="1A1A1A"/>
                 </a:solidFill>
@@ -4160,13 +4188,13 @@
               <a:t>PSO2, PSO3 </a:t>
             </a:r>
             <a:r>
-              <a:rPr sz="2400" b="0">
-                <a:solidFill>
-                  <a:srgbClr val="1A1A1A"/>
-                </a:solidFill>
-                <a:latin typeface="Calibri"/>
-              </a:rPr>
-              <a:t>Analysis and imaging of biosignals (fMRI) with modern tools.</a:t>
+              <a:rPr sz="2550" b="0">
+                <a:solidFill>
+                  <a:srgbClr val="1A1A1A"/>
+                </a:solidFill>
+                <a:latin typeface="Calibri"/>
+              </a:rPr>
+              <a:t>fMRI analysis and imaging with modern tools.</a:t>
             </a:r>
           </a:p>
         </p:txBody>
@@ -4761,6 +4789,34 @@
               <a:t>enabling research, not a deployed device; the contribution is evidence of what non-invasive decoding can and cannot achieve.</a:t>
             </a:r>
           </a:p>
+          <a:p>
+            <a:pPr>
+              <a:lnSpc>
+                <a:spcPct val="105000"/>
+              </a:lnSpc>
+              <a:spcAft>
+                <a:spcPts val="1400"/>
+              </a:spcAft>
+            </a:pPr>
+            <a:r>
+              <a:rPr sz="2500" b="1">
+                <a:solidFill>
+                  <a:srgbClr val="1A1A1A"/>
+                </a:solidFill>
+                <a:latin typeface="Calibri"/>
+              </a:rPr>
+              <a:t>Responsible use: </a:t>
+            </a:r>
+            <a:r>
+              <a:rPr sz="2500" b="0">
+                <a:solidFill>
+                  <a:srgbClr val="1A1A1A"/>
+                </a:solidFill>
+                <a:latin typeface="Calibri"/>
+              </a:rPr>
+              <a:t>the inverse identifies which known moment was heard but does not reconstruct thought, evidence for mental-privacy policy (OECD 2019, UNESCO 2025). No new human data collected.</a:t>
+            </a:r>
+          </a:p>
         </p:txBody>
       </p:sp>
       <p:sp>
@@ -5026,7 +5082,7 @@
                 </a:solidFill>
                 <a:latin typeface="Calibri"/>
               </a:rPr>
-              <a:t>Forward-only barrier test along solution differences; Jacobian sensitivity vs 200 random directions.</a:t>
+              <a:t>Agreement between fit-matched solutions; forward-only probes along their difference; Jacobian sensitivity vs 200 random directions.</a:t>
             </a:r>
           </a:p>
           <a:p>
@@ -5045,7 +5101,7 @@
                 </a:solidFill>
                 <a:latin typeface="Calibri"/>
               </a:rPr>
-              <a:t>5  Regions and real data. </a:t>
+              <a:t>5  Regions. </a:t>
             </a:r>
             <a:r>
               <a:rPr sz="2600" b="0">
@@ -5054,7 +5110,35 @@
                 </a:solidFill>
                 <a:latin typeface="Calibri"/>
               </a:rPr>
-              <a:t>6 Destrieux networks vs size-matched random sets; LeBel 2023 fMRI projected to fsaverage5, held-out story.</a:t>
+              <a:t>6 Destrieux networks vs size-matched random vertex sets, with a second random seed as the control spread.</a:t>
+            </a:r>
+          </a:p>
+          <a:p>
+            <a:pPr>
+              <a:lnSpc>
+                <a:spcPct val="105000"/>
+              </a:lnSpc>
+              <a:spcAft>
+                <a:spcPts val="800"/>
+              </a:spcAft>
+            </a:pPr>
+            <a:r>
+              <a:rPr sz="2600" b="1">
+                <a:solidFill>
+                  <a:srgbClr val="1A1A1A"/>
+                </a:solidFill>
+                <a:latin typeface="Calibri"/>
+              </a:rPr>
+              <a:t>6  Real fMRI. </a:t>
+            </a:r>
+            <a:r>
+              <a:rPr sz="2600" b="0">
+                <a:solidFill>
+                  <a:srgbClr val="1A1A1A"/>
+                </a:solidFill>
+                <a:latin typeface="Calibri"/>
+              </a:rPr>
+              <a:t>LeBel 2023 subject UTS03 projected to fsaverage5; lag and vertices chosen on five training stories; held-out story inverted and ranked among 45 segments.</a:t>
             </a:r>
           </a:p>
           <a:p>
@@ -5590,6 +5674,35 @@
               <a:t>Inverse-problem theory, deep learning, neuroimaging (surface registration, atlases) and neuroanatomy must work together.</a:t>
             </a:r>
           </a:p>
+          <a:p>
+            <a:pPr marL="274320" indent="-228600">
+              <a:lnSpc>
+                <a:spcPct val="105000"/>
+              </a:lnSpc>
+              <a:spcAft>
+                <a:spcPts val="900"/>
+              </a:spcAft>
+              <a:buChar char="•"/>
+            </a:pPr>
+            <a:r>
+              <a:rPr sz="2700" b="1">
+                <a:solidFill>
+                  <a:srgbClr val="1A1A1A"/>
+                </a:solidFill>
+                <a:latin typeface="Calibri"/>
+              </a:rPr>
+              <a:t>Scale on free hardware. </a:t>
+            </a:r>
+            <a:r>
+              <a:rPr sz="2700" b="0">
+                <a:solidFill>
+                  <a:srgbClr val="1A1A1A"/>
+                </a:solidFill>
+                <a:latin typeface="Calibri"/>
+              </a:rPr>
+              <a:t>20 484 × 100 outputs per pass, tens of thousands of passes per experiment, one 15 GB GPU.</a:t>
+            </a:r>
+          </a:p>
         </p:txBody>
       </p:sp>
       <p:sp>
@@ -5989,6 +6102,35 @@
               <a:t>Dr. Sharmila Nageswaran, Associate Professor, School of Electronics Engineering (SENSE), VIT Vellore</a:t>
             </a:r>
           </a:p>
+          <a:p>
+            <a:pPr marL="274320" indent="-228600">
+              <a:lnSpc>
+                <a:spcPct val="105000"/>
+              </a:lnSpc>
+              <a:spcAft>
+                <a:spcPts val="1000"/>
+              </a:spcAft>
+              <a:buChar char="•"/>
+            </a:pPr>
+            <a:r>
+              <a:rPr sz="2900" b="1">
+                <a:solidFill>
+                  <a:srgbClr val="1A1A1A"/>
+                </a:solidFill>
+                <a:latin typeface="Calibri"/>
+              </a:rPr>
+              <a:t>Effort: </a:t>
+            </a:r>
+            <a:r>
+              <a:rPr sz="2900" b="0">
+                <a:solidFill>
+                  <a:srgbClr val="1A1A1A"/>
+                </a:solidFill>
+                <a:latin typeface="Calibri"/>
+              </a:rPr>
+              <a:t>580 person-hours (330 + 250), seven stages, August–October 2026</a:t>
+            </a:r>
+          </a:p>
         </p:txBody>
       </p:sp>
       <p:sp>
@@ -6161,7 +6303,7 @@
                 </a:solidFill>
                 <a:latin typeface="Calibri"/>
               </a:rPr>
-              <a:t>Brain encoding models predict fMRI from what a person sees and hears; decoding runs the other way. We ask whether a near-perfect encoder can simply be inverted to read meaning back out of the brain.</a:t>
+              <a:t>Encoding models predict fMRI from what a person sees and hears; decoding runs the other way. Can a near-perfect encoder simply be inverted to read meaning back out?</a:t>
             </a:r>
           </a:p>
           <a:p>
@@ -6199,6 +6341,34 @@
                 <a:latin typeface="Calibri"/>
               </a:rPr>
               <a:t> with exact ground truth, and validate on real fMRI from a held-out story.</a:t>
+            </a:r>
+          </a:p>
+          <a:p>
+            <a:pPr>
+              <a:lnSpc>
+                <a:spcPct val="105000"/>
+              </a:lnSpc>
+              <a:spcAft>
+                <a:spcPts val="1000"/>
+              </a:spcAft>
+            </a:pPr>
+            <a:r>
+              <a:rPr sz="2900" b="1">
+                <a:solidFill>
+                  <a:srgbClr val="1A1A1A"/>
+                </a:solidFill>
+                <a:latin typeface="Calibri"/>
+              </a:rPr>
+              <a:t>Answer: no. </a:t>
+            </a:r>
+            <a:r>
+              <a:rPr sz="2900" b="0">
+                <a:solidFill>
+                  <a:srgbClr val="1A1A1A"/>
+                </a:solidFill>
+                <a:latin typeface="Calibri"/>
+              </a:rPr>
+              <a:t>Error falls 28.4× while recovery saturates; on real fMRI 4 of 5 held-out segments are identified (chance 2.2%), yet cosine to the truth is only 0.02.</a:t>
             </a:r>
           </a:p>
         </p:txBody>
@@ -6367,13 +6537,13 @@
               </a:spcAft>
             </a:pPr>
             <a:r>
-              <a:rPr sz="1700" b="0">
-                <a:solidFill>
-                  <a:srgbClr val="1A1A1A"/>
-                </a:solidFill>
-                <a:latin typeface="Calibri"/>
-              </a:rPr>
-              <a:t>[1] S. d'Ascoli et al., TRIBE v2, arXiv:2605.04326, 2026.  [2] J. L. Gardner, T. Liu, eNeuro 6(2), 2019.  [3] J. Tang et al., Nat. Neurosci. 26, 2023.  [4] A. LeBel et al., Sci. Data 10, 555, 2023.  [5] K. N. Kay et al., Nature 452, 2008.  [6] P. C. Hansen, Discrete Inverse Problems, SIAM, 2010.  [7] J. Lévy et al., arXiv:2502.17480, 2025.  [8] C. Destrieux et al., NeuroImage 53, 2010.</a:t>
+              <a:rPr sz="1850" b="0">
+                <a:solidFill>
+                  <a:srgbClr val="1A1A1A"/>
+                </a:solidFill>
+                <a:latin typeface="Calibri"/>
+              </a:rPr>
+              <a:t>[1] S. d'Ascoli et al., TRIBE v2, arXiv:2605.04326, 2026.  [2] J. L. Gardner, T. Liu, eNeuro 6(2), 2019.  [3] J. Tang et al., Nat. Neurosci. 26, 858–866, 2023.  [4] A. LeBel et al., Sci. Data 10, 555, 2023.  [5] K. N. Kay et al., Nature 452, 352–355, 2008.  [6] P. C. Hansen, Discrete Inverse Problems, SIAM, 2010.  [7] J. Lévy et al., arXiv:2502.17480, 2025.  [8] C. Destrieux et al., NeuroImage 53, 1–15, 2010.  [9] T. Naselaris et al., NeuroImage 56, 400–410, 2011.  [10] A. G. Huth et al., Nature 532, 453–458, 2016.  [11] R. Antonello et al., NeurIPS 36, 2023.  [12] A. T. Gifford et al., arXiv:2501.00504, 2025.  [13] B. Lahner et al., Nat. Commun. 15, 6241, 2024.  [14] Q. K. Telesford et al., Sci. Data 10, 554, 2023.  [15] C. M. Michel et al., Clin. Neurophysiol. 115, 2195–2222, 2004.</a:t>
             </a:r>
           </a:p>
         </p:txBody>
@@ -6538,26 +6708,118 @@
                 <a:spcPct val="105000"/>
               </a:lnSpc>
               <a:spcAft>
-                <a:spcPts val="0"/>
+                <a:spcPts val="500"/>
               </a:spcAft>
             </a:pPr>
             <a:r>
-              <a:rPr sz="1800" b="1">
-                <a:solidFill>
-                  <a:srgbClr val="1A1A1A"/>
-                </a:solidFill>
-                <a:latin typeface="Calibri"/>
-              </a:rPr>
-              <a:t>Complete and reproducible: </a:t>
-            </a:r>
-            <a:r>
-              <a:rPr sz="1800" b="0">
-                <a:solidFill>
-                  <a:srgbClr val="1A1A1A"/>
-                </a:solidFill>
-                <a:latin typeface="Calibri"/>
-              </a:rPr>
-              <a:t>IEEE-format manuscript (ready for submission), open GitHub repository with code, results, demo video and Colab notebooks, review decks and this poster. Finding: encoding accuracy does not certify decoding; measure recoverability.</a:t>
+              <a:rPr sz="2000" b="1">
+                <a:solidFill>
+                  <a:srgbClr val="1A1A1A"/>
+                </a:solidFill>
+                <a:latin typeface="Calibri"/>
+              </a:rPr>
+              <a:t>Manuscript: </a:t>
+            </a:r>
+            <a:r>
+              <a:rPr sz="2000" b="0">
+                <a:solidFill>
+                  <a:srgbClr val="1A1A1A"/>
+                </a:solidFill>
+                <a:latin typeface="Calibri"/>
+              </a:rPr>
+              <a:t>IEEE-format paper, A. Sarkar*, T. Choudhuri*, S. Nageswaran; ready for submission.  </a:t>
+            </a:r>
+            <a:r>
+              <a:rPr sz="2000" b="1">
+                <a:solidFill>
+                  <a:srgbClr val="1A1A1A"/>
+                </a:solidFill>
+                <a:latin typeface="Calibri"/>
+              </a:rPr>
+              <a:t>Report: </a:t>
+            </a:r>
+            <a:r>
+              <a:rPr sz="2000" b="0">
+                <a:solidFill>
+                  <a:srgbClr val="1A1A1A"/>
+                </a:solidFill>
+                <a:latin typeface="Calibri"/>
+              </a:rPr>
+              <a:t>final Project-I report in the 2026 VIT format.</a:t>
+            </a:r>
+          </a:p>
+          <a:p>
+            <a:pPr>
+              <a:lnSpc>
+                <a:spcPct val="105000"/>
+              </a:lnSpc>
+              <a:spcAft>
+                <a:spcPts val="500"/>
+              </a:spcAft>
+            </a:pPr>
+            <a:r>
+              <a:rPr sz="2000" b="1">
+                <a:solidFill>
+                  <a:srgbClr val="1A1A1A"/>
+                </a:solidFill>
+                <a:latin typeface="Calibri"/>
+              </a:rPr>
+              <a:t>Open release: </a:t>
+            </a:r>
+            <a:r>
+              <a:rPr sz="2000" b="0">
+                <a:solidFill>
+                  <a:srgbClr val="1A1A1A"/>
+                </a:solidFill>
+                <a:latin typeface="Calibri"/>
+              </a:rPr>
+              <a:t>GitHub repository (QR code above) with all code, logged results, an interactive live demo and four Colab notebooks, including a live run of TRIBE v2.  </a:t>
+            </a:r>
+            <a:r>
+              <a:rPr sz="2000" b="1">
+                <a:solidFill>
+                  <a:srgbClr val="1A1A1A"/>
+                </a:solidFill>
+                <a:latin typeface="Calibri"/>
+              </a:rPr>
+              <a:t>Cost: </a:t>
+            </a:r>
+            <a:r>
+              <a:rPr sz="2000" b="0">
+                <a:solidFill>
+                  <a:srgbClr val="1A1A1A"/>
+                </a:solidFill>
+                <a:latin typeface="Calibri"/>
+              </a:rPr>
+              <a:t>₹0 compute on free GPUs.</a:t>
+            </a:r>
+          </a:p>
+          <a:p>
+            <a:pPr>
+              <a:lnSpc>
+                <a:spcPct val="105000"/>
+              </a:lnSpc>
+              <a:spcAft>
+                <a:spcPts val="500"/>
+              </a:spcAft>
+            </a:pPr>
+            <a:r>
+              <a:rPr sz="2000" b="1">
+                <a:solidFill>
+                  <a:srgbClr val="1A1A1A"/>
+                </a:solidFill>
+                <a:latin typeface="Calibri"/>
+              </a:rPr>
+              <a:t>Finding: </a:t>
+            </a:r>
+            <a:r>
+              <a:rPr sz="2000" b="0">
+                <a:solidFill>
+                  <a:srgbClr val="1A1A1A"/>
+                </a:solidFill>
+                <a:latin typeface="Calibri"/>
+              </a:rPr>
+              <a:t>encoding accuracy does not certify decoding; recoverability must be measured, region by region.</a:t>
             </a:r>
           </a:p>
         </p:txBody>
@@ -7671,7 +7933,7 @@
                 </a:solidFill>
                 <a:latin typeface="Calibri"/>
               </a:rPr>
-              <a:t>Controls: inits × 4 truths, barrier test, ROI vs random</a:t>
+              <a:t>Controls: 8 inits × 4 truths, sensitivity, ROI vs random</a:t>
             </a:r>
           </a:p>
         </p:txBody>
@@ -7720,7 +7982,7 @@
         </p:nvGraphicFramePr>
         <p:xfrm>
           <a:off x="731520" y="28026360"/>
-          <a:ext cx="13944600" cy="3291840"/>
+          <a:ext cx="13944600" cy="3730752"/>
         </p:xfrm>
         <a:graphic>
           <a:graphicData uri="http://schemas.openxmlformats.org/drawingml/2006/table">
@@ -7735,7 +7997,7 @@
                 <a:gridCol w="2286000"/>
                 <a:gridCol w="2011680"/>
               </a:tblGrid>
-              <a:tr h="548640">
+              <a:tr h="621792">
                 <a:tc>
                   <a:txBody>
                     <a:bodyPr wrap="square"/>
@@ -7743,7 +8005,7 @@
                     <a:p>
                       <a:pPr algn="l"/>
                       <a:r>
-                        <a:rPr sz="1900" b="1">
+                        <a:rPr sz="2000" b="1">
                           <a:solidFill>
                             <a:srgbClr val="FFFFFF"/>
                           </a:solidFill>
@@ -7766,7 +8028,7 @@
                     <a:p>
                       <a:pPr algn="ctr"/>
                       <a:r>
-                        <a:rPr sz="1900" b="1">
+                        <a:rPr sz="2000" b="1">
                           <a:solidFill>
                             <a:srgbClr val="FFFFFF"/>
                           </a:solidFill>
@@ -7789,7 +8051,7 @@
                     <a:p>
                       <a:pPr algn="ctr"/>
                       <a:r>
-                        <a:rPr sz="1900" b="1">
+                        <a:rPr sz="2000" b="1">
                           <a:solidFill>
                             <a:srgbClr val="FFFFFF"/>
                           </a:solidFill>
@@ -7812,7 +8074,7 @@
                     <a:p>
                       <a:pPr algn="ctr"/>
                       <a:r>
-                        <a:rPr sz="1900" b="1">
+                        <a:rPr sz="2000" b="1">
                           <a:solidFill>
                             <a:srgbClr val="FFFFFF"/>
                           </a:solidFill>
@@ -7835,7 +8097,7 @@
                     <a:p>
                       <a:pPr algn="ctr"/>
                       <a:r>
-                        <a:rPr sz="1900" b="1">
+                        <a:rPr sz="2000" b="1">
                           <a:solidFill>
                             <a:srgbClr val="FFFFFF"/>
                           </a:solidFill>
@@ -7852,7 +8114,7 @@
                   </a:tcPr>
                 </a:tc>
               </a:tr>
-              <a:tr h="548640">
+              <a:tr h="621792">
                 <a:tc>
                   <a:txBody>
                     <a:bodyPr wrap="square"/>
@@ -7860,7 +8122,7 @@
                     <a:p>
                       <a:pPr algn="l"/>
                       <a:r>
-                        <a:rPr sz="1900" b="0">
+                        <a:rPr sz="2000" b="0">
                           <a:solidFill>
                             <a:srgbClr val="1A1A1A"/>
                           </a:solidFill>
@@ -7883,7 +8145,7 @@
                     <a:p>
                       <a:pPr algn="ctr"/>
                       <a:r>
-                        <a:rPr sz="1900" b="0">
+                        <a:rPr sz="2000" b="0">
                           <a:solidFill>
                             <a:srgbClr val="1A1A1A"/>
                           </a:solidFill>
@@ -7906,7 +8168,7 @@
                     <a:p>
                       <a:pPr algn="ctr"/>
                       <a:r>
-                        <a:rPr sz="1900" b="0">
+                        <a:rPr sz="2000" b="0">
                           <a:solidFill>
                             <a:srgbClr val="1A1A1A"/>
                           </a:solidFill>
@@ -7929,7 +8191,7 @@
                     <a:p>
                       <a:pPr algn="ctr"/>
                       <a:r>
-                        <a:rPr sz="1900" b="0">
+                        <a:rPr sz="2000" b="0">
                           <a:solidFill>
                             <a:srgbClr val="1A1A1A"/>
                           </a:solidFill>
@@ -7952,7 +8214,7 @@
                     <a:p>
                       <a:pPr algn="ctr"/>
                       <a:r>
-                        <a:rPr sz="1900" b="0">
+                        <a:rPr sz="2000" b="0">
                           <a:solidFill>
                             <a:srgbClr val="1A1A1A"/>
                           </a:solidFill>
@@ -7969,7 +8231,7 @@
                   </a:tcPr>
                 </a:tc>
               </a:tr>
-              <a:tr h="548640">
+              <a:tr h="621792">
                 <a:tc>
                   <a:txBody>
                     <a:bodyPr wrap="square"/>
@@ -7977,7 +8239,7 @@
                     <a:p>
                       <a:pPr algn="l"/>
                       <a:r>
-                        <a:rPr sz="1900" b="0">
+                        <a:rPr sz="2000" b="0">
                           <a:solidFill>
                             <a:srgbClr val="1A1A1A"/>
                           </a:solidFill>
@@ -8000,7 +8262,7 @@
                     <a:p>
                       <a:pPr algn="ctr"/>
                       <a:r>
-                        <a:rPr sz="1900" b="0">
+                        <a:rPr sz="2000" b="0">
                           <a:solidFill>
                             <a:srgbClr val="1A1A1A"/>
                           </a:solidFill>
@@ -8023,7 +8285,7 @@
                     <a:p>
                       <a:pPr algn="ctr"/>
                       <a:r>
-                        <a:rPr sz="1900" b="0">
+                        <a:rPr sz="2000" b="0">
                           <a:solidFill>
                             <a:srgbClr val="1A1A1A"/>
                           </a:solidFill>
@@ -8046,7 +8308,7 @@
                     <a:p>
                       <a:pPr algn="ctr"/>
                       <a:r>
-                        <a:rPr sz="1900" b="0">
+                        <a:rPr sz="2000" b="0">
                           <a:solidFill>
                             <a:srgbClr val="1A1A1A"/>
                           </a:solidFill>
@@ -8069,7 +8331,7 @@
                     <a:p>
                       <a:pPr algn="ctr"/>
                       <a:r>
-                        <a:rPr sz="1900" b="0">
+                        <a:rPr sz="2000" b="0">
                           <a:solidFill>
                             <a:srgbClr val="1A1A1A"/>
                           </a:solidFill>
@@ -8086,7 +8348,7 @@
                   </a:tcPr>
                 </a:tc>
               </a:tr>
-              <a:tr h="548640">
+              <a:tr h="621792">
                 <a:tc>
                   <a:txBody>
                     <a:bodyPr wrap="square"/>
@@ -8094,7 +8356,7 @@
                     <a:p>
                       <a:pPr algn="l"/>
                       <a:r>
-                        <a:rPr sz="1900" b="0">
+                        <a:rPr sz="2000" b="0">
                           <a:solidFill>
                             <a:srgbClr val="1A1A1A"/>
                           </a:solidFill>
@@ -8117,7 +8379,7 @@
                     <a:p>
                       <a:pPr algn="ctr"/>
                       <a:r>
-                        <a:rPr sz="1900" b="0">
+                        <a:rPr sz="2000" b="0">
                           <a:solidFill>
                             <a:srgbClr val="1A1A1A"/>
                           </a:solidFill>
@@ -8140,7 +8402,7 @@
                     <a:p>
                       <a:pPr algn="ctr"/>
                       <a:r>
-                        <a:rPr sz="1900" b="0">
+                        <a:rPr sz="2000" b="0">
                           <a:solidFill>
                             <a:srgbClr val="1A1A1A"/>
                           </a:solidFill>
@@ -8163,7 +8425,7 @@
                     <a:p>
                       <a:pPr algn="ctr"/>
                       <a:r>
-                        <a:rPr sz="1900" b="0">
+                        <a:rPr sz="2000" b="0">
                           <a:solidFill>
                             <a:srgbClr val="1A1A1A"/>
                           </a:solidFill>
@@ -8186,7 +8448,7 @@
                     <a:p>
                       <a:pPr algn="ctr"/>
                       <a:r>
-                        <a:rPr sz="1900" b="0">
+                        <a:rPr sz="2000" b="0">
                           <a:solidFill>
                             <a:srgbClr val="1A1A1A"/>
                           </a:solidFill>
@@ -8203,7 +8465,7 @@
                   </a:tcPr>
                 </a:tc>
               </a:tr>
-              <a:tr h="548640">
+              <a:tr h="621792">
                 <a:tc>
                   <a:txBody>
                     <a:bodyPr wrap="square"/>
@@ -8211,7 +8473,7 @@
                     <a:p>
                       <a:pPr algn="l"/>
                       <a:r>
-                        <a:rPr sz="1900" b="0">
+                        <a:rPr sz="2000" b="0">
                           <a:solidFill>
                             <a:srgbClr val="1A1A1A"/>
                           </a:solidFill>
@@ -8234,7 +8496,7 @@
                     <a:p>
                       <a:pPr algn="ctr"/>
                       <a:r>
-                        <a:rPr sz="1900" b="0">
+                        <a:rPr sz="2000" b="0">
                           <a:solidFill>
                             <a:srgbClr val="1A1A1A"/>
                           </a:solidFill>
@@ -8257,7 +8519,7 @@
                     <a:p>
                       <a:pPr algn="ctr"/>
                       <a:r>
-                        <a:rPr sz="1900" b="0">
+                        <a:rPr sz="2000" b="0">
                           <a:solidFill>
                             <a:srgbClr val="1A1A1A"/>
                           </a:solidFill>
@@ -8280,7 +8542,7 @@
                     <a:p>
                       <a:pPr algn="ctr"/>
                       <a:r>
-                        <a:rPr sz="1900" b="0">
+                        <a:rPr sz="2000" b="0">
                           <a:solidFill>
                             <a:srgbClr val="1A1A1A"/>
                           </a:solidFill>
@@ -8303,7 +8565,7 @@
                     <a:p>
                       <a:pPr algn="ctr"/>
                       <a:r>
-                        <a:rPr sz="1900" b="0">
+                        <a:rPr sz="2000" b="0">
                           <a:solidFill>
                             <a:srgbClr val="1A1A1A"/>
                           </a:solidFill>
@@ -8320,7 +8582,7 @@
                   </a:tcPr>
                 </a:tc>
               </a:tr>
-              <a:tr h="548640">
+              <a:tr h="621792">
                 <a:tc>
                   <a:txBody>
                     <a:bodyPr wrap="square"/>
@@ -8328,7 +8590,7 @@
                     <a:p>
                       <a:pPr algn="l"/>
                       <a:r>
-                        <a:rPr sz="1900" b="1">
+                        <a:rPr sz="2000" b="1">
                           <a:solidFill>
                             <a:srgbClr val="1A1A1A"/>
                           </a:solidFill>
@@ -8351,7 +8613,7 @@
                     <a:p>
                       <a:pPr algn="ctr"/>
                       <a:r>
-                        <a:rPr sz="1900" b="1">
+                        <a:rPr sz="2000" b="1">
                           <a:solidFill>
                             <a:srgbClr val="1A1A1A"/>
                           </a:solidFill>
@@ -8374,7 +8636,7 @@
                     <a:p>
                       <a:pPr algn="ctr"/>
                       <a:r>
-                        <a:rPr sz="1900" b="1">
+                        <a:rPr sz="2000" b="1">
                           <a:solidFill>
                             <a:srgbClr val="1A1A1A"/>
                           </a:solidFill>
@@ -8397,7 +8659,7 @@
                     <a:p>
                       <a:pPr algn="ctr"/>
                       <a:r>
-                        <a:rPr sz="1900" b="1">
+                        <a:rPr sz="2000" b="1">
                           <a:solidFill>
                             <a:srgbClr val="1A1A1A"/>
                           </a:solidFill>
@@ -8420,7 +8682,7 @@
                     <a:p>
                       <a:pPr algn="ctr"/>
                       <a:r>
-                        <a:rPr sz="1900" b="1">
+                        <a:rPr sz="2000" b="1">
                           <a:solidFill>
                             <a:srgbClr val="1A1A1A"/>
                           </a:solidFill>
@@ -8449,7 +8711,7 @@
         </p:nvSpPr>
         <p:spPr>
           <a:xfrm>
-            <a:off x="731520" y="31501080"/>
+            <a:off x="731520" y="31912560"/>
             <a:ext cx="13944600" cy="1280160"/>
           </a:xfrm>
           <a:prstGeom prst="rect">
@@ -8501,7 +8763,7 @@
       </p:pic>
       <p:pic>
         <p:nvPicPr>
-          <p:cNvPr id="61" name="Picture 60" descr="fig_nullspace_test.png"/>
+          <p:cNvPr id="61" name="Picture 60" descr="fig_nonconvex.png"/>
           <p:cNvPicPr>
             <a:picLocks noChangeAspect="1"/>
           </p:cNvPicPr>
@@ -8515,8 +8777,8 @@
         </p:blipFill>
         <p:spPr>
           <a:xfrm>
-            <a:off x="23199123" y="22082760"/>
-            <a:ext cx="5740841" cy="3474720"/>
+            <a:off x="22594824" y="22430231"/>
+            <a:ext cx="6949440" cy="2779776"/>
           </a:xfrm>
           <a:prstGeom prst="rect">
             <a:avLst/>
@@ -8609,7 +8871,7 @@
                 </a:solidFill>
                 <a:latin typeface="Calibri"/>
               </a:rPr>
-              <a:t>error ↓28.4× but recovery saturates (0.944); equal fits disagree (cosine 0.817); barrier, not null space. </a:t>
+              <a:t>error ↓28.4× but recovery saturates (0.944); equally good fits disagree (min. cosine 0.817 over 4 truths); errors lie in weakly sensed directions. </a:t>
             </a:r>
             <a:r>
               <a:rPr sz="1700" b="1">

</xml_diff>

<commit_message>
Corrected barrier test: fit-matched blind pairs and straight-path profiles; update report, poster, demo, docs; fix pair selection
</commit_message>
<xml_diff>
--- a/poster/Poster_Sarkar_Choudhuri_Project1.pptx
+++ b/poster/Poster_Sarkar_Choudhuri_Project1.pptx
@@ -5082,7 +5082,7 @@
                 </a:solidFill>
                 <a:latin typeface="Calibri"/>
               </a:rPr>
-              <a:t>Agreement between fit-matched solutions; forward-only probes along their difference; Jacobian sensitivity vs 200 random directions.</a:t>
+              <a:t>Agreement of fit-matched solutions; forward-only straight-path barrier test; Jacobian sensitivity vs 200 random directions.</a:t>
             </a:r>
           </a:p>
           <a:p>
@@ -7933,7 +7933,7 @@
                 </a:solidFill>
                 <a:latin typeface="Calibri"/>
               </a:rPr>
-              <a:t>Controls: 8 inits × 4 truths, sensitivity, ROI vs random</a:t>
+              <a:t>Controls: 8 inits × 4 truths, barrier, ROI vs random</a:t>
             </a:r>
           </a:p>
         </p:txBody>
@@ -8763,7 +8763,7 @@
       </p:pic>
       <p:pic>
         <p:nvPicPr>
-          <p:cNvPr id="61" name="Picture 60" descr="fig_nonconvex.png"/>
+          <p:cNvPr id="61" name="Picture 60" descr="fig_barrier_path.png"/>
           <p:cNvPicPr>
             <a:picLocks noChangeAspect="1"/>
           </p:cNvPicPr>
@@ -8777,8 +8777,8 @@
         </p:blipFill>
         <p:spPr>
           <a:xfrm>
-            <a:off x="22594824" y="22430231"/>
-            <a:ext cx="6949440" cy="2779776"/>
+            <a:off x="22760286" y="22082760"/>
+            <a:ext cx="6618514" cy="3474720"/>
           </a:xfrm>
           <a:prstGeom prst="rect">
             <a:avLst/>
@@ -8871,7 +8871,7 @@
                 </a:solidFill>
                 <a:latin typeface="Calibri"/>
               </a:rPr>
-              <a:t>error ↓28.4× but recovery saturates (0.944); equally good fits disagree (min. cosine 0.817 over 4 truths); errors lie in weakly sensed directions. </a:t>
+              <a:t>error ↓28.4× but recovery saturates (0.944); equal fits disagree (0.817) and sit in separate minima (path barrier 3.8×; 7.2× to a deeper one). </a:t>
             </a:r>
             <a:r>
               <a:rPr sz="1700" b="1">

</xml_diff>

<commit_message>
Poster: thousands separators as commas (text and ROI figure)
</commit_message>
<xml_diff>
--- a/poster/Poster_Sarkar_Choudhuri_Project1.pptx
+++ b/poster/Poster_Sarkar_Choudhuri_Project1.pptx
@@ -5166,7 +5166,7 @@
                 </a:solidFill>
                 <a:latin typeface="Calibri"/>
               </a:rPr>
-              <a:t>millimetre detail on 20 484 vertices, the only deep encoder large enough to invert, and one inverse problem instead of two (EEG adds source localisation). EEG is faster and cheaper, which matters for a device, not for this measurement.</a:t>
+              <a:t>millimetre detail on 20,484 vertices, the only deep encoder large enough to invert, and one inverse problem instead of two (EEG adds source localisation). EEG is faster and cheaper, which matters for a device, not for this measurement.</a:t>
             </a:r>
           </a:p>
         </p:txBody>
@@ -5526,7 +5526,7 @@
                 </a:solidFill>
                 <a:latin typeface="Calibri"/>
               </a:rPr>
-              <a:t>The forward model is a 177 M-parameter nonlinear transformer mapping a 32 × 1 152 representation to 20 484 cortical vertices; its inverse cannot be written down and must be measured.</a:t>
+              <a:t>The forward model is a 177 M-parameter nonlinear transformer mapping a 32 × 1,152 representation to 20,484 cortical vertices; its inverse cannot be written down and must be measured.</a:t>
             </a:r>
           </a:p>
           <a:p>
@@ -5700,7 +5700,7 @@
                 </a:solidFill>
                 <a:latin typeface="Calibri"/>
               </a:rPr>
-              <a:t>20 484 × 100 outputs per pass, tens of thousands of passes per experiment, one 15 GB GPU.</a:t>
+              <a:t>20,484 × 100 outputs per pass, tens of thousands of passes per experiment, one 15 GB GPU.</a:t>
             </a:r>
           </a:p>
         </p:txBody>
@@ -7121,7 +7121,7 @@
                 </a:solidFill>
                 <a:latin typeface="Calibri"/>
               </a:rPr>
-              <a:t>32 × 1 152 (free)</a:t>
+              <a:t>32 × 1,152 (free)</a:t>
             </a:r>
           </a:p>
         </p:txBody>
@@ -7365,7 +7365,7 @@
                 </a:solidFill>
                 <a:latin typeface="Calibri"/>
               </a:rPr>
-              <a:t>20 484 vertices</a:t>
+              <a:t>20,484 vertices</a:t>
             </a:r>
           </a:p>
         </p:txBody>

</xml_diff>

<commit_message>
Report and poster: guide's review changes (commas, third person, statements only, executive summary sections, software costs, front-page alignment)
</commit_message>
<xml_diff>
--- a/poster/Poster_Sarkar_Choudhuri_Project1.pptx
+++ b/poster/Poster_Sarkar_Choudhuri_Project1.pptx
@@ -4702,7 +4702,7 @@
                 </a:solidFill>
                 <a:latin typeface="Calibri"/>
               </a:rPr>
-              <a:t>well-being for people with ALS, stroke or locked-in syndrome who keep comprehension but lose speech: we measure what non-invasive decoding can deliver.</a:t>
+              <a:t>well-being for people with ALS, stroke or locked-in syndrome who keep comprehension but lose speech: the project measures the limits of non-invasive decoding.</a:t>
             </a:r>
           </a:p>
           <a:p>
@@ -4786,7 +4786,7 @@
                 </a:solidFill>
                 <a:latin typeface="Calibri"/>
               </a:rPr>
-              <a:t>enabling research, not a deployed device; the contribution is evidence of what non-invasive decoding can and cannot achieve.</a:t>
+              <a:t>enabling research, not a deployed device; the contribution is evidence on the achievable limits of non-invasive decoding.</a:t>
             </a:r>
           </a:p>
           <a:p>
@@ -5138,7 +5138,7 @@
                 </a:solidFill>
                 <a:latin typeface="Calibri"/>
               </a:rPr>
-              <a:t>LeBel 2023 subject UTS03 projected to fsaverage5; lag and vertices chosen on five training stories; held-out story inverted and ranked among 45 segments.</a:t>
+              <a:t>LeBel 2023 subject UTS03 projected to fsaverage5; lag and vertices chosen on five training stories; a story unseen in TRIBE v2's training inverted and ranked among 45 segments.</a:t>
             </a:r>
           </a:p>
           <a:p>
@@ -5157,7 +5157,7 @@
                 </a:solidFill>
                 <a:latin typeface="Calibri"/>
               </a:rPr>
-              <a:t>Why fMRI, not EEG: </a:t>
+              <a:t>fMRI over EEG: </a:t>
             </a:r>
             <a:r>
               <a:rPr sz="2600" b="0">
@@ -5584,7 +5584,7 @@
                 </a:solidFill>
                 <a:latin typeface="Calibri"/>
               </a:rPr>
-              <a:t>The true meaning behind a brain recording is unknown, so we built a synthetic framework with exact error, then a real-fMRI test with identification at a known chance level.</a:t>
+              <a:t>The true meaning behind a brain recording is unknown, so a synthetic framework with exact error was built, followed by a real-fMRI test with identification at a known chance level.</a:t>
             </a:r>
           </a:p>
           <a:p>
@@ -5613,7 +5613,7 @@
                 </a:solidFill>
                 <a:latin typeface="Calibri"/>
               </a:rPr>
-              <a:t>The released pipeline is not differentiable (speech synthesis, transcription, frozen extractors); we found and re-entered the one differentiable boundary.</a:t>
+              <a:t>The released pipeline is not differentiable (speech synthesis, transcription, frozen extractors); the one differentiable boundary was located and re-entered.</a:t>
             </a:r>
           </a:p>
           <a:p>
@@ -6303,7 +6303,7 @@
                 </a:solidFill>
                 <a:latin typeface="Calibri"/>
               </a:rPr>
-              <a:t>Encoding models predict fMRI from what a person sees and hears; decoding runs the other way. Can a near-perfect encoder simply be inverted to read meaning back out?</a:t>
+              <a:t>Encoding models predict fMRI from the stimuli a person sees and hears; decoding runs the other way. This project tests whether a near-perfect encoder can be inverted to read meaning back out.</a:t>
             </a:r>
           </a:p>
           <a:p>
@@ -6322,7 +6322,7 @@
                 </a:solidFill>
                 <a:latin typeface="Calibri"/>
               </a:rPr>
-              <a:t>We invert Meta's open 177 M-parameter TRIBE v2 encoder by gradient descent, measure </a:t>
+              <a:t>Meta's open 177 M-parameter TRIBE v2 encoder is inverted by gradient descent; its </a:t>
             </a:r>
             <a:r>
               <a:rPr sz="2900" b="1">
@@ -6340,7 +6340,7 @@
                 </a:solidFill>
                 <a:latin typeface="Calibri"/>
               </a:rPr>
-              <a:t> with exact ground truth, and validate on real fMRI from a held-out story.</a:t>
+              <a:t> are measured with exact ground truth and validated on real fMRI from a story unseen in training.</a:t>
             </a:r>
           </a:p>
           <a:p>
@@ -6359,7 +6359,7 @@
                 </a:solidFill>
                 <a:latin typeface="Calibri"/>
               </a:rPr>
-              <a:t>Answer: no. </a:t>
+              <a:t>Finding: </a:t>
             </a:r>
             <a:r>
               <a:rPr sz="2900" b="0">
@@ -6368,7 +6368,7 @@
                 </a:solidFill>
                 <a:latin typeface="Calibri"/>
               </a:rPr>
-              <a:t>Error falls 28.4× while recovery saturates; on real fMRI 4 of 5 held-out segments are identified (chance 2.2%), yet cosine to the truth is only 0.02.</a:t>
+              <a:t>error falls 28.4× while recovery saturates; on real fMRI 4 of 5 unseen test segments are identified (chance 2.2%), yet cosine to the truth is only 0.02.</a:t>
             </a:r>
           </a:p>
         </p:txBody>
@@ -6773,7 +6773,7 @@
                 </a:solidFill>
                 <a:latin typeface="Calibri"/>
               </a:rPr>
-              <a:t>GitHub repository (QR code above) with all code, logged results, an interactive live demo and four Colab notebooks, including a live run of TRIBE v2.  </a:t>
+              <a:t>GitHub repository (QR code above): code, logged results, interactive demo, four Colab notebooks.  </a:t>
             </a:r>
             <a:r>
               <a:rPr sz="2000" b="1">
@@ -6782,7 +6782,7 @@
                 </a:solidFill>
                 <a:latin typeface="Calibri"/>
               </a:rPr>
-              <a:t>Cost: </a:t>
+              <a:t>Tools and cost: </a:t>
             </a:r>
             <a:r>
               <a:rPr sz="2000" b="0">
@@ -6791,7 +6791,7 @@
                 </a:solidFill>
                 <a:latin typeface="Calibri"/>
               </a:rPr>
-              <a:t>₹0 compute on free GPUs.</a:t>
+              <a:t>Python, PyTorch, nilearn, Colab (free T4), GitHub, Google Drive, MS Word and PowerPoint (VIT licence), LibreOffice: ₹0; printing only.</a:t>
             </a:r>
           </a:p>
           <a:p>
@@ -8596,7 +8596,7 @@
                           </a:solidFill>
                           <a:latin typeface="Calibri"/>
                         </a:rPr>
-                        <a:t>This work</a:t>
+                        <a:t>Proposed work</a:t>
                       </a:r>
                     </a:p>
                   </a:txBody>

</xml_diff>

<commit_message>
Poster: subscription prices in tools and cost
</commit_message>
<xml_diff>
--- a/poster/Poster_Sarkar_Choudhuri_Project1.pptx
+++ b/poster/Poster_Sarkar_Choudhuri_Project1.pptx
@@ -4730,7 +4730,7 @@
                 </a:solidFill>
                 <a:latin typeface="Calibri"/>
               </a:rPr>
-              <a:t>open, reproducible research capability in neural-interface engineering on free compute.</a:t>
+              <a:t>open, reproducible research capability in neural-interface engineering on low-cost cloud compute.</a:t>
             </a:r>
           </a:p>
           <a:p>
@@ -5691,7 +5691,7 @@
                 </a:solidFill>
                 <a:latin typeface="Calibri"/>
               </a:rPr>
-              <a:t>Scale on free hardware. </a:t>
+              <a:t>Scale on modest hardware. </a:t>
             </a:r>
             <a:r>
               <a:rPr sz="2700" b="0">
@@ -6727,25 +6727,7 @@
                 </a:solidFill>
                 <a:latin typeface="Calibri"/>
               </a:rPr>
-              <a:t>IEEE-format paper, A. Sarkar*, T. Choudhuri*, S. Nageswaran; ready for submission.  </a:t>
-            </a:r>
-            <a:r>
-              <a:rPr sz="2000" b="1">
-                <a:solidFill>
-                  <a:srgbClr val="1A1A1A"/>
-                </a:solidFill>
-                <a:latin typeface="Calibri"/>
-              </a:rPr>
-              <a:t>Report: </a:t>
-            </a:r>
-            <a:r>
-              <a:rPr sz="2000" b="0">
-                <a:solidFill>
-                  <a:srgbClr val="1A1A1A"/>
-                </a:solidFill>
-                <a:latin typeface="Calibri"/>
-              </a:rPr>
-              <a:t>final Project-I report in the 2026 VIT format.</a:t>
+              <a:t>IEEE-format paper, A. Sarkar*, T. Choudhuri*, S. Nageswaran; ready for submission.</a:t>
             </a:r>
           </a:p>
           <a:p>
@@ -6791,7 +6773,7 @@
                 </a:solidFill>
                 <a:latin typeface="Calibri"/>
               </a:rPr>
-              <a:t>Python, PyTorch, nilearn, Colab (free T4), GitHub, Google Drive, MS Word and PowerPoint (VIT licence), LibreOffice: ₹0; printing only.</a:t>
+              <a:t>Colab Pro ₹950/mo (US$9.99), Google One 200 GB ₹210/mo, Microsoft 365 ₹689/mo, GitHub Pro ₹380/mo (US$4): ₹2,229/mo, ₹6,687 for Aug–Oct 2026 + printing; Python, PyTorch, nilearn, LibreOffice: no licence fee.</a:t>
             </a:r>
           </a:p>
           <a:p>

</xml_diff>